<commit_message>
content(fifty-states): wreckmatch 2026-06-04T17 UTC
</commit_message>
<xml_diff>
--- a/public/blog/presentations/semi-truck-accident-in-seattle-washington-what-to-do-2026.pptx
+++ b/public/blog/presentations/semi-truck-accident-in-seattle-washington-what-to-do-2026.pptx
@@ -592,7 +592,7 @@
           <a:p/>
           <a:p>
             <a:r>
-              <a:t>Reviewed for legal context by Hon. Ret. Judge Roy Waddell, Legal Advisor at WreckMatch LLC — courtroom and procedural perspective only; not legal advice for your specific case.</a:t>
+              <a:t>Reviewed for legal context by Judge Roy Waddell, Legal Advisor at WreckMatch LLC — courtroom and procedural perspective only; not legal advice for your specific case.</a:t>
             </a:r>
           </a:p>
           <a:p/>
@@ -4662,7 +4662,7 @@
               </a:defRPr>
             </a:pPr>
             <a:r>
-              <a:t>Truck Accidents · Washington · 2026-05-31</a:t>
+              <a:t>Truck Accidents · Washington · 2026-05-30</a:t>
             </a:r>
           </a:p>
         </p:txBody>

</xml_diff>